<commit_message>
upload: COMrade ABE Analysis
</commit_message>
<xml_diff>
--- a/16_COMrade_ABE_Analysis.pptx
+++ b/16_COMrade_ABE_Analysis.pptx
@@ -30946,6 +30946,25 @@
               <a:sym typeface="Montserrat SemiBold"/>
             </a:endParaRPr>
           </a:p>
+          <a:p>
+            <a:pPr marL="177800" lvl="2" indent="-177800">
+              <a:buSzPts val="1600"/>
+              <a:buFont typeface="Arial" panose="020B0604020202020204" pitchFamily="34" charset="0"/>
+              <a:buChar char="•"/>
+            </a:pPr>
+            <a:r>
+              <a:rPr lang="en-US" altLang="ko-KR" sz="1000">
+                <a:solidFill>
+                  <a:schemeClr val="dk1"/>
+                </a:solidFill>
+                <a:latin typeface="페이퍼로지 4 Regular" charset="-127"/>
+                <a:ea typeface="페이퍼로지 4 Regular" charset="-127"/>
+                <a:cs typeface="Montserrat SemiBold"/>
+                <a:sym typeface="Montserrat SemiBold"/>
+              </a:rPr>
+              <a:t>check_method_signature(self, method_name, fd, ti): </a:t>
+            </a:r>
+          </a:p>
         </p:txBody>
       </p:sp>
       <p:sp>

</xml_diff>